<commit_message>
fix(slides): strip raw wikilinks from generated slide decks [KOEA-1274]
Wikilink handler in clean_line() was converting [[path]] to raw path text.
Now: course/ refs resolve to academy URLs, research/ refs become readable
labels, other internal refs omit cleanly.

Fixes S4 ([[research/openai/2026-04-29]]) and S6 ([[course/claude-tool-use-from-zero]])
blockers on openai-on-aws-bedrock-the-real-tradeoffs slides.

Co-Authored-By: Claude Sonnet 4.6 <noreply@anthropic.com>
</commit_message>
<xml_diff>
--- a/vault/blogs/2026-04-30-openai-on-aws-bedrock-the-real-tradeoffs/slides.pptx
+++ b/vault/blogs/2026-04-30-openai-on-aws-bedrock-the-real-tradeoffs/slides.pptx
@@ -3984,7 +3984,7 @@
                   <a:srgbClr val="FFFFFF"/>
                 </a:solidFill>
               </a:rPr>
-              <a:t>  See [[research/openai/2026-04-29]] for the original research note that flagged this announcement as a hot signal.</a:t>
+              <a:t>  See the research note for the original research note that flagged this announcement as a hot signal.</a:t>
             </a:r>
           </a:p>
         </p:txBody>
@@ -4462,7 +4462,7 @@
                   <a:srgbClr val="FFFFFF"/>
                 </a:solidFill>
               </a:rPr>
-              <a:t>  For teams new to both Bedrock and multi-model IAM patterns, [[course/claude-tool-use-from-zero]] walks through the found</a:t>
+              <a:t>  For teams new to both Bedrock and multi-model IAM patterns, academy.kspl.tech/courses/claude-tool-use-from-zero walks th</a:t>
             </a:r>
           </a:p>
         </p:txBody>

</xml_diff>